<commit_message>
Declutter slide 16: collapse the classical baselines into a band
Four near-coincident daily curves, a legend box sitting on top of them and
every rebalance date on the x-axis read as one grey smudge when projected —
the axis on the left panel was literally unreadable.

The claim the slide makes is "everything tracks, nothing breaks away", and a
band states that better than four overlapping strokes. The three classical
baselines become their own min–max envelope, leaving one emphasised line
against it: two visual elements per panel instead of four, a shared legend
below both, round y-ticks (100 / 125 / 150 …) instead of 10^2 scientific
notation, and year ticks instead of collided month stamps.

Nothing is aggregated away silently: the band is labelled with the three
strategies it contains, the caption says which edge is which, the speaker note
explains it, and the exact Sharpe ratios stay on annex slide A.

Co-Authored-By: Claude Opus 5 <noreply@anthropic.com>
</commit_message>
<xml_diff>
--- a/output/presentation/Soutenance_PFA_Vulgarisee_FR.pptx
+++ b/output/presentation/Soutenance_PFA_Vulgarisee_FR.pptx
@@ -1016,7 +1016,7 @@
           <a:lstStyle/>
           <a:p>
             <a:r>
-              <a:t>Les résultats, hors échantillon et nets de frais. Les stratégies se tiennent, y compris à travers 2008, 2020 et 2022 — aucune ne décroche. La vraie question n’est donc pas « est-ce que ça marche », mais « l’écart entre ces courbes est-il réel ». C’est exactement ce que la chaîne sait trancher. [~60 s]</a:t>
+              <a:t>Les résultats, hors échantillon et nets de frais. La bande bleue claire, c’est l’ensemble des références classiques : son bord bas est la moins bonne, son bord haut la meilleure. La ligne foncée est notre système à régimes. Il reste dans la bande du début à la fin, 2008, 2020 et 2022 compris. La vraie question n’est donc pas « est-ce que ça marche », mais « l’écart est-il réel ou dans le bruit » — et c’est exactement ce que la chaîne sait trancher. [~60 s]</a:t>
             </a:r>
           </a:p>
         </p:txBody>
@@ -9582,14 +9582,14 @@
                 </a:solidFill>
                 <a:latin typeface="Arial"/>
               </a:rPr>
-              <a:t>À gauche l’univers mixte marocain, à droite vingt ans d’ETF internationaux couvrant 2008, 2020 et 2022.</a:t>
+              <a:t>Deux terrains évalués séparément : quatre ans au Maroc, vingt ans à l’international — 2008, 2020 et 2022 compris.</a:t>
             </a:r>
           </a:p>
         </p:txBody>
       </p:sp>
       <p:pic>
         <p:nvPicPr>
-          <p:cNvPr id="6" name="Picture 5" descr="courbes_equity.png"/>
+          <p:cNvPr id="6" name="Picture 5" descr="courbes_equity_fr.png"/>
           <p:cNvPicPr>
             <a:picLocks noChangeAspect="1"/>
           </p:cNvPicPr>
@@ -9603,8 +9603,8 @@
         </p:blipFill>
         <p:spPr>
           <a:xfrm>
-            <a:off x="1587656" y="1498600"/>
-            <a:ext cx="9016687" cy="4064000"/>
+            <a:off x="951955" y="1320800"/>
+            <a:ext cx="10288089" cy="4622800"/>
           </a:xfrm>
           <a:prstGeom prst="rect">
             <a:avLst/>
@@ -9619,8 +9619,8 @@
         </p:nvSpPr>
         <p:spPr>
           <a:xfrm>
-            <a:off x="609600" y="5689600"/>
-            <a:ext cx="10972800" cy="787400"/>
+            <a:off x="609600" y="6045200"/>
+            <a:ext cx="10972800" cy="660400"/>
           </a:xfrm>
           <a:prstGeom prst="roundRect">
             <a:avLst>
@@ -9665,8 +9665,8 @@
         </p:nvSpPr>
         <p:spPr>
           <a:xfrm>
-            <a:off x="889000" y="5867400"/>
-            <a:ext cx="10414000" cy="508000"/>
+            <a:off x="889000" y="6210300"/>
+            <a:ext cx="10414000" cy="431800"/>
           </a:xfrm>
           <a:prstGeom prst="rect">
             <a:avLst/>
@@ -9691,7 +9691,7 @@
                 </a:solidFill>
                 <a:latin typeface="Arial"/>
               </a:rPr>
-              <a:t>Les stratégies se tiennent : aucune ne décroche, y compris à travers les crises. La question n’est donc pas « est-ce que ça marche »,</a:t>
+              <a:t>La bande couvre les trois références classiques, du moins au mieux. Le système ML reste dedans d’un bout à l’autre, crises comprises :</a:t>
             </a:r>
           </a:p>
           <a:p>
@@ -9707,7 +9707,7 @@
                 </a:solidFill>
                 <a:latin typeface="Arial"/>
               </a:rPr>
-              <a:t>mais « l’écart entre ces courbes est-il réel ou dans le bruit » — et c’est précisément ce que la chaîne sait trancher.</a:t>
+              <a:t>la question n’est donc pas « est-ce que ça marche », mais « l’écart est-il réel ou dans le bruit » — et c’est ce que la chaîne sait trancher.</a:t>
             </a:r>
           </a:p>
         </p:txBody>

</xml_diff>